<commit_message>
presentation _ mahmoud v2
</commit_message>
<xml_diff>
--- a/RANPilotAi_Graduation_Project_BOOK/presentation.pptx
+++ b/RANPilotAi_Graduation_Project_BOOK/presentation.pptx
@@ -1553,6 +1553,13 @@
         </dgm:presLayoutVars>
       </dgm:prSet>
       <dgm:spPr/>
+      <dgm:t>
+        <a:bodyPr/>
+        <a:lstStyle/>
+        <a:p>
+          <a:endParaRPr lang="en-US"/>
+        </a:p>
+      </dgm:t>
     </dgm:pt>
     <dgm:pt modelId="{93D76702-C2A8-4552-960B-C2CCD4981C99}" type="pres">
       <dgm:prSet presAssocID="{DE0D542D-D583-46F8-AF81-5963C844620D}" presName="linNode" presStyleCnt="0"/>
@@ -1636,6 +1643,13 @@
         </dgm:presLayoutVars>
       </dgm:prSet>
       <dgm:spPr/>
+      <dgm:t>
+        <a:bodyPr/>
+        <a:lstStyle/>
+        <a:p>
+          <a:endParaRPr lang="en-US"/>
+        </a:p>
+      </dgm:t>
     </dgm:pt>
     <dgm:pt modelId="{B220DA74-EC66-489D-8246-311B923B97F4}" type="pres">
       <dgm:prSet presAssocID="{8D2AE69D-74F5-4BBB-BCDD-A101C39C3368}" presName="spV" presStyleCnt="0"/>
@@ -1676,6 +1690,13 @@
         </dgm:presLayoutVars>
       </dgm:prSet>
       <dgm:spPr/>
+      <dgm:t>
+        <a:bodyPr/>
+        <a:lstStyle/>
+        <a:p>
+          <a:endParaRPr lang="en-US"/>
+        </a:p>
+      </dgm:t>
     </dgm:pt>
     <dgm:pt modelId="{61C6EDBC-202D-45B6-90DB-576D020436A6}" type="pres">
       <dgm:prSet presAssocID="{78A00466-42E4-4EC0-9E29-CCB271DF42F4}" presName="spV" presStyleCnt="0"/>
@@ -1857,48 +1878,55 @@
         </dgm:presLayoutVars>
       </dgm:prSet>
       <dgm:spPr/>
+      <dgm:t>
+        <a:bodyPr/>
+        <a:lstStyle/>
+        <a:p>
+          <a:endParaRPr lang="en-US"/>
+        </a:p>
+      </dgm:t>
     </dgm:pt>
   </dgm:ptLst>
   <dgm:cxnLst>
-    <dgm:cxn modelId="{91C5D652-BEDF-41BC-8F3B-05BE92152759}" type="presOf" srcId="{96D22CE3-E99B-43B7-A890-8B3328F8E2E0}" destId="{824F19CC-5252-49CF-BB92-9DDE5C78A83D}" srcOrd="0" destOrd="1" presId="urn:diagrams.loki3.com/BracketList"/>
+    <dgm:cxn modelId="{51656E9E-C438-4269-8BAA-86F019163B07}" srcId="{D4570B03-06D1-496E-940D-E834C1A39D15}" destId="{DE0D542D-D583-46F8-AF81-5963C844620D}" srcOrd="0" destOrd="0" parTransId="{C8EF2553-001E-4794-9586-0CDE54007ADD}" sibTransId="{FB29F8EB-EE92-45C5-8BCF-B06C4D9BC7DC}"/>
     <dgm:cxn modelId="{E4C5A6E7-BD51-49BE-B462-C60D6912FD6F}" type="presOf" srcId="{B6EA1160-7F8A-4126-8376-C44E264E6EA1}" destId="{4D2CC661-966E-4BA4-843D-A1C1153050D7}" srcOrd="0" destOrd="0" presId="urn:diagrams.loki3.com/BracketList"/>
-    <dgm:cxn modelId="{F0A4654E-4223-438B-A830-452AC96E48E2}" type="presOf" srcId="{20D280F0-91E7-42CA-9A03-571050C0CB16}" destId="{051F707C-CB75-4D21-8C13-082BD2FF2D14}" srcOrd="0" destOrd="1" presId="urn:diagrams.loki3.com/BracketList"/>
+    <dgm:cxn modelId="{38475AF4-CAB8-417F-B300-5B7AFA14E6E2}" srcId="{D4570B03-06D1-496E-940D-E834C1A39D15}" destId="{CFC255E3-F313-4F68-A8BE-AA9A0E7B2920}" srcOrd="4" destOrd="0" parTransId="{80D5B58A-7533-437A-907C-7A96D4C934CD}" sibTransId="{AF699248-E40C-4F45-8095-1040C5E7766E}"/>
     <dgm:cxn modelId="{9CA15018-9C07-46DF-90DA-8AF065446E5E}" type="presOf" srcId="{39F54975-3C18-4047-B841-1E5ED79DA055}" destId="{D1E7592D-5481-4E23-BBA9-37FC11FDB1FC}" srcOrd="0" destOrd="0" presId="urn:diagrams.loki3.com/BracketList"/>
+    <dgm:cxn modelId="{56A8B0BB-481F-4E64-8165-87BB69F9A22B}" srcId="{D4570B03-06D1-496E-940D-E834C1A39D15}" destId="{67AAB135-0D51-4F78-B9C5-116756FDD4FD}" srcOrd="6" destOrd="0" parTransId="{0764D504-CB07-4071-9A74-C38D1F4EC718}" sibTransId="{AE1B9AE7-854E-4E8A-9B49-3CA8614B49B7}"/>
+    <dgm:cxn modelId="{29685408-45E5-4A09-A94C-6B5811184DDF}" type="presOf" srcId="{9357E48B-E7E0-4CA0-9ABC-FF0F47D16FFF}" destId="{2E54DBD1-1915-453C-B205-7D57F6596F56}" srcOrd="0" destOrd="0" presId="urn:diagrams.loki3.com/BracketList"/>
+    <dgm:cxn modelId="{AD4ED5EC-FC39-42A5-BC4B-7545101D5B7F}" type="presOf" srcId="{02D6A755-2659-4714-A019-A60BD2DBF44D}" destId="{AC2B96A3-ADBA-40C0-B958-7DDD08E7D4E8}" srcOrd="0" destOrd="0" presId="urn:diagrams.loki3.com/BracketList"/>
     <dgm:cxn modelId="{F6E88605-19FE-4705-B7C4-F462D8AB4643}" srcId="{67AAB135-0D51-4F78-B9C5-116756FDD4FD}" destId="{B8004FBE-713E-4F15-8885-85B9EA6E9A18}" srcOrd="0" destOrd="0" parTransId="{8A89D8F8-211F-464D-AF74-1F8DE05387B4}" sibTransId="{CA806B09-F251-46F6-807A-781E4FCD5974}"/>
-    <dgm:cxn modelId="{38475AF4-CAB8-417F-B300-5B7AFA14E6E2}" srcId="{D4570B03-06D1-496E-940D-E834C1A39D15}" destId="{CFC255E3-F313-4F68-A8BE-AA9A0E7B2920}" srcOrd="4" destOrd="0" parTransId="{80D5B58A-7533-437A-907C-7A96D4C934CD}" sibTransId="{AF699248-E40C-4F45-8095-1040C5E7766E}"/>
-    <dgm:cxn modelId="{E5D3C6D9-77FA-4A53-B8D1-9AFC12914D57}" srcId="{D4570B03-06D1-496E-940D-E834C1A39D15}" destId="{E5D331DA-30E0-4D9E-AF95-9BED1C00B881}" srcOrd="3" destOrd="0" parTransId="{0EEC3D0D-1968-4D98-B1E4-5BE2E7C9D046}" sibTransId="{0D12E0D9-447A-4318-A2D1-567184552CEB}"/>
-    <dgm:cxn modelId="{56A8B0BB-481F-4E64-8165-87BB69F9A22B}" srcId="{D4570B03-06D1-496E-940D-E834C1A39D15}" destId="{67AAB135-0D51-4F78-B9C5-116756FDD4FD}" srcOrd="6" destOrd="0" parTransId="{0764D504-CB07-4071-9A74-C38D1F4EC718}" sibTransId="{AE1B9AE7-854E-4E8A-9B49-3CA8614B49B7}"/>
-    <dgm:cxn modelId="{79185F44-6415-43D5-957F-294E77A373C5}" type="presOf" srcId="{F73F6B60-F387-4B00-AF21-983EFA908F3B}" destId="{824F19CC-5252-49CF-BB92-9DDE5C78A83D}" srcOrd="0" destOrd="0" presId="urn:diagrams.loki3.com/BracketList"/>
     <dgm:cxn modelId="{E9038612-49E6-4585-9419-CEFEF22E5596}" srcId="{D4570B03-06D1-496E-940D-E834C1A39D15}" destId="{02D6A755-2659-4714-A019-A60BD2DBF44D}" srcOrd="1" destOrd="0" parTransId="{A11D1553-18D4-4D46-8E28-8FA6B27EC28B}" sibTransId="{8D2AE69D-74F5-4BBB-BCDD-A101C39C3368}"/>
-    <dgm:cxn modelId="{48925DAF-9D7D-48B1-915F-91E9E63EDFE3}" type="presOf" srcId="{016B6379-197D-4014-BBB5-7272361FA5ED}" destId="{A85E5853-DBE3-4294-93EB-D0C052772C14}" srcOrd="0" destOrd="0" presId="urn:diagrams.loki3.com/BracketList"/>
-    <dgm:cxn modelId="{8FE8D121-64DD-4D0A-B1E3-B860DA31B65D}" type="presOf" srcId="{67AAB135-0D51-4F78-B9C5-116756FDD4FD}" destId="{E4B80767-5737-4482-A6AF-D1C6CDF122DC}" srcOrd="0" destOrd="0" presId="urn:diagrams.loki3.com/BracketList"/>
-    <dgm:cxn modelId="{CBDABCD5-9B7D-42F1-9295-22DC73E2FDB0}" srcId="{67AAB135-0D51-4F78-B9C5-116756FDD4FD}" destId="{20D280F0-91E7-42CA-9A03-571050C0CB16}" srcOrd="1" destOrd="0" parTransId="{731ED404-621E-4ED2-85AD-DF4BDFC2D3BD}" sibTransId="{C2E8C2C7-E4B0-46E1-AD5C-037C095ABDF0}"/>
-    <dgm:cxn modelId="{C2E89A0B-866F-45C1-9E43-09B489A3A4E8}" srcId="{D4570B03-06D1-496E-940D-E834C1A39D15}" destId="{39F54975-3C18-4047-B841-1E5ED79DA055}" srcOrd="5" destOrd="0" parTransId="{CEC1D58E-1AB3-4E72-A00C-84BAD892CD40}" sibTransId="{5DDE273F-5EAF-4DCF-9576-3CC5E69C990E}"/>
-    <dgm:cxn modelId="{A96622E3-BC84-4F67-BC21-F7E183C9238B}" srcId="{CFC255E3-F313-4F68-A8BE-AA9A0E7B2920}" destId="{EF4D839F-1954-4FEA-BC1D-6A6FE5E5C4E4}" srcOrd="1" destOrd="0" parTransId="{ABA9D00D-FA58-4C5C-A960-9BF9EC11A01B}" sibTransId="{BFF19C4C-6C38-488B-B9A1-292A32DD8C60}"/>
-    <dgm:cxn modelId="{175A0D4F-E174-43F2-8F85-B67FCA281E1A}" srcId="{CFC255E3-F313-4F68-A8BE-AA9A0E7B2920}" destId="{DFD7F550-E826-4DB8-852E-70462049B908}" srcOrd="0" destOrd="0" parTransId="{F769BD8D-0698-445D-897D-E2A2FA3FF3AC}" sibTransId="{DD95DAB0-10DD-49AD-A13D-0FF303E43A7B}"/>
-    <dgm:cxn modelId="{CED7CC02-254C-4CB5-AA30-2B25713B0DE9}" srcId="{02D6A755-2659-4714-A019-A60BD2DBF44D}" destId="{D19DA2C2-DBED-4C48-A059-92B1F02E952E}" srcOrd="1" destOrd="0" parTransId="{2411435A-2DED-45FE-BAF2-EA5E2BAB2221}" sibTransId="{8B1C7915-ACF1-48A9-8CBC-03BA5CAA0EC8}"/>
     <dgm:cxn modelId="{4BE1A33F-8709-45AC-9866-A77B712F0F4B}" srcId="{DE0D542D-D583-46F8-AF81-5963C844620D}" destId="{D12CF5CC-B0AB-4657-8BC8-05A2DA36F5F4}" srcOrd="0" destOrd="0" parTransId="{6A3B3684-783F-4816-9363-23FED4B817AB}" sibTransId="{443C1D04-5678-4F60-8A9D-9083BCA3E12E}"/>
     <dgm:cxn modelId="{8CD274B0-EC7A-409C-AB2D-56C7534B144B}" type="presOf" srcId="{E5D331DA-30E0-4D9E-AF95-9BED1C00B881}" destId="{51EE0D49-AD04-4513-87AC-4148C700764C}" srcOrd="0" destOrd="0" presId="urn:diagrams.loki3.com/BracketList"/>
     <dgm:cxn modelId="{BEBC4F50-0997-43E0-A4F6-3DCF33909B4C}" srcId="{D4570B03-06D1-496E-940D-E834C1A39D15}" destId="{B6EA1160-7F8A-4126-8376-C44E264E6EA1}" srcOrd="2" destOrd="0" parTransId="{C4A29E89-B10D-4EE9-817D-665085164D56}" sibTransId="{78A00466-42E4-4EC0-9E29-CCB271DF42F4}"/>
-    <dgm:cxn modelId="{51656E9E-C438-4269-8BAA-86F019163B07}" srcId="{D4570B03-06D1-496E-940D-E834C1A39D15}" destId="{DE0D542D-D583-46F8-AF81-5963C844620D}" srcOrd="0" destOrd="0" parTransId="{C8EF2553-001E-4794-9586-0CDE54007ADD}" sibTransId="{FB29F8EB-EE92-45C5-8BCF-B06C4D9BC7DC}"/>
-    <dgm:cxn modelId="{D60FD02C-D5E8-494B-B039-6EEC522D73AE}" type="presOf" srcId="{B8004FBE-713E-4F15-8885-85B9EA6E9A18}" destId="{051F707C-CB75-4D21-8C13-082BD2FF2D14}" srcOrd="0" destOrd="0" presId="urn:diagrams.loki3.com/BracketList"/>
+    <dgm:cxn modelId="{E148A8F3-3E98-4E38-A6A3-BF7236721D64}" type="presOf" srcId="{EF4D839F-1954-4FEA-BC1D-6A6FE5E5C4E4}" destId="{A5768B98-F77A-4129-ACD5-EDDCB6DCE048}" srcOrd="0" destOrd="1" presId="urn:diagrams.loki3.com/BracketList"/>
+    <dgm:cxn modelId="{BB10DE44-0E64-4D65-BC2C-C5E23F3B4B7E}" type="presOf" srcId="{B410AD1F-A2B3-49B3-8BE2-CA1B2963672B}" destId="{16433D64-952C-4A31-983D-1017B3C32C47}" srcOrd="0" destOrd="1" presId="urn:diagrams.loki3.com/BracketList"/>
+    <dgm:cxn modelId="{C8A7134D-29D6-4AE5-AFFB-1706BB271EEA}" type="presOf" srcId="{DE0D542D-D583-46F8-AF81-5963C844620D}" destId="{EEF1E03F-C7C5-4626-9C13-2E78DD1D4267}" srcOrd="0" destOrd="0" presId="urn:diagrams.loki3.com/BracketList"/>
+    <dgm:cxn modelId="{79185F44-6415-43D5-957F-294E77A373C5}" type="presOf" srcId="{F73F6B60-F387-4B00-AF21-983EFA908F3B}" destId="{824F19CC-5252-49CF-BB92-9DDE5C78A83D}" srcOrd="0" destOrd="0" presId="urn:diagrams.loki3.com/BracketList"/>
+    <dgm:cxn modelId="{CBDABCD5-9B7D-42F1-9295-22DC73E2FDB0}" srcId="{67AAB135-0D51-4F78-B9C5-116756FDD4FD}" destId="{20D280F0-91E7-42CA-9A03-571050C0CB16}" srcOrd="1" destOrd="0" parTransId="{731ED404-621E-4ED2-85AD-DF4BDFC2D3BD}" sibTransId="{C2E8C2C7-E4B0-46E1-AD5C-037C095ABDF0}"/>
     <dgm:cxn modelId="{AEBFEC2D-8855-4E2E-BEE0-C2AC6A2AD198}" type="presOf" srcId="{D12CF5CC-B0AB-4657-8BC8-05A2DA36F5F4}" destId="{16433D64-952C-4A31-983D-1017B3C32C47}" srcOrd="0" destOrd="0" presId="urn:diagrams.loki3.com/BracketList"/>
-    <dgm:cxn modelId="{06F5ADC8-64CC-416E-A504-58BD95BE6371}" type="presOf" srcId="{D19DA2C2-DBED-4C48-A059-92B1F02E952E}" destId="{2E54DBD1-1915-453C-B205-7D57F6596F56}" srcOrd="0" destOrd="1" presId="urn:diagrams.loki3.com/BracketList"/>
+    <dgm:cxn modelId="{F6B286A8-B838-48A2-8EA3-C6AA8D365595}" srcId="{E5D331DA-30E0-4D9E-AF95-9BED1C00B881}" destId="{F73F6B60-F387-4B00-AF21-983EFA908F3B}" srcOrd="0" destOrd="0" parTransId="{66BC6DEB-3BCA-40D4-BBDB-03469584A26B}" sibTransId="{F9A40652-90E5-4569-99B1-02A0DB0C497F}"/>
+    <dgm:cxn modelId="{175A0D4F-E174-43F2-8F85-B67FCA281E1A}" srcId="{CFC255E3-F313-4F68-A8BE-AA9A0E7B2920}" destId="{DFD7F550-E826-4DB8-852E-70462049B908}" srcOrd="0" destOrd="0" parTransId="{F769BD8D-0698-445D-897D-E2A2FA3FF3AC}" sibTransId="{DD95DAB0-10DD-49AD-A13D-0FF303E43A7B}"/>
+    <dgm:cxn modelId="{91C5D652-BEDF-41BC-8F3B-05BE92152759}" type="presOf" srcId="{96D22CE3-E99B-43B7-A890-8B3328F8E2E0}" destId="{824F19CC-5252-49CF-BB92-9DDE5C78A83D}" srcOrd="0" destOrd="1" presId="urn:diagrams.loki3.com/BracketList"/>
+    <dgm:cxn modelId="{81E2E479-FF41-415B-B38F-7F0297466D91}" type="presOf" srcId="{D4570B03-06D1-496E-940D-E834C1A39D15}" destId="{49162F80-9F02-44A6-B8BB-9C145D32E9A6}" srcOrd="0" destOrd="0" presId="urn:diagrams.loki3.com/BracketList"/>
+    <dgm:cxn modelId="{48925DAF-9D7D-48B1-915F-91E9E63EDFE3}" type="presOf" srcId="{016B6379-197D-4014-BBB5-7272361FA5ED}" destId="{A85E5853-DBE3-4294-93EB-D0C052772C14}" srcOrd="0" destOrd="0" presId="urn:diagrams.loki3.com/BracketList"/>
     <dgm:cxn modelId="{84B90654-B9B2-4F49-B93C-7AB9B1513360}" type="presOf" srcId="{CFC255E3-F313-4F68-A8BE-AA9A0E7B2920}" destId="{1988FC77-CF36-4CB7-8B74-1CB63D2CB4BE}" srcOrd="0" destOrd="0" presId="urn:diagrams.loki3.com/BracketList"/>
-    <dgm:cxn modelId="{253CA61A-3D10-40C6-A6A5-EB9F6A55F5B0}" type="presOf" srcId="{E382FAAA-4FB2-477A-98B3-A2A120BAC348}" destId="{68C4F1F0-2F56-483B-8104-BEA79A7538A1}" srcOrd="0" destOrd="0" presId="urn:diagrams.loki3.com/BracketList"/>
-    <dgm:cxn modelId="{BB10DE44-0E64-4D65-BC2C-C5E23F3B4B7E}" type="presOf" srcId="{B410AD1F-A2B3-49B3-8BE2-CA1B2963672B}" destId="{16433D64-952C-4A31-983D-1017B3C32C47}" srcOrd="0" destOrd="1" presId="urn:diagrams.loki3.com/BracketList"/>
-    <dgm:cxn modelId="{E8C2E0BE-83B9-42FF-9F2F-0017F48DCA71}" srcId="{DE0D542D-D583-46F8-AF81-5963C844620D}" destId="{B410AD1F-A2B3-49B3-8BE2-CA1B2963672B}" srcOrd="1" destOrd="0" parTransId="{703C4DDF-2819-43E6-95F5-DEA0F213ACDA}" sibTransId="{CCBF6D02-9F0B-4236-9549-FD1FC07A5984}"/>
-    <dgm:cxn modelId="{29685408-45E5-4A09-A94C-6B5811184DDF}" type="presOf" srcId="{9357E48B-E7E0-4CA0-9ABC-FF0F47D16FFF}" destId="{2E54DBD1-1915-453C-B205-7D57F6596F56}" srcOrd="0" destOrd="0" presId="urn:diagrams.loki3.com/BracketList"/>
-    <dgm:cxn modelId="{81E2E479-FF41-415B-B38F-7F0297466D91}" type="presOf" srcId="{D4570B03-06D1-496E-940D-E834C1A39D15}" destId="{49162F80-9F02-44A6-B8BB-9C145D32E9A6}" srcOrd="0" destOrd="0" presId="urn:diagrams.loki3.com/BracketList"/>
-    <dgm:cxn modelId="{3456690B-B173-48B8-86F7-97252F1597D5}" srcId="{E5D331DA-30E0-4D9E-AF95-9BED1C00B881}" destId="{96D22CE3-E99B-43B7-A890-8B3328F8E2E0}" srcOrd="1" destOrd="0" parTransId="{3DA8366F-C933-44CA-ADDF-18F73189EA6A}" sibTransId="{A42478D0-807D-4203-8347-8182C244F189}"/>
-    <dgm:cxn modelId="{F6B286A8-B838-48A2-8EA3-C6AA8D365595}" srcId="{E5D331DA-30E0-4D9E-AF95-9BED1C00B881}" destId="{F73F6B60-F387-4B00-AF21-983EFA908F3B}" srcOrd="0" destOrd="0" parTransId="{66BC6DEB-3BCA-40D4-BBDB-03469584A26B}" sibTransId="{F9A40652-90E5-4569-99B1-02A0DB0C497F}"/>
-    <dgm:cxn modelId="{86FD203E-7063-4D5F-A35C-3598D65669ED}" srcId="{02D6A755-2659-4714-A019-A60BD2DBF44D}" destId="{9357E48B-E7E0-4CA0-9ABC-FF0F47D16FFF}" srcOrd="0" destOrd="0" parTransId="{7581C13E-E6C9-4383-A784-20E62B70B3DC}" sibTransId="{F31CFC71-E692-4437-B605-955BBEFE5B3C}"/>
-    <dgm:cxn modelId="{E148A8F3-3E98-4E38-A6A3-BF7236721D64}" type="presOf" srcId="{EF4D839F-1954-4FEA-BC1D-6A6FE5E5C4E4}" destId="{A5768B98-F77A-4129-ACD5-EDDCB6DCE048}" srcOrd="0" destOrd="1" presId="urn:diagrams.loki3.com/BracketList"/>
-    <dgm:cxn modelId="{AD4ED5EC-FC39-42A5-BC4B-7545101D5B7F}" type="presOf" srcId="{02D6A755-2659-4714-A019-A60BD2DBF44D}" destId="{AC2B96A3-ADBA-40C0-B958-7DDD08E7D4E8}" srcOrd="0" destOrd="0" presId="urn:diagrams.loki3.com/BracketList"/>
-    <dgm:cxn modelId="{99E6DEB9-6BD5-4EFC-87D0-EC8AA52BEB00}" srcId="{39F54975-3C18-4047-B841-1E5ED79DA055}" destId="{E382FAAA-4FB2-477A-98B3-A2A120BAC348}" srcOrd="0" destOrd="0" parTransId="{A26A0720-9BE4-44E9-89C9-7F9980634043}" sibTransId="{92B8D365-A3DA-4EE7-BA70-DC7D10A7653D}"/>
     <dgm:cxn modelId="{A9446154-ADD1-42B0-A05A-FEA847BCBE80}" type="presOf" srcId="{DFD7F550-E826-4DB8-852E-70462049B908}" destId="{A5768B98-F77A-4129-ACD5-EDDCB6DCE048}" srcOrd="0" destOrd="0" presId="urn:diagrams.loki3.com/BracketList"/>
     <dgm:cxn modelId="{35C42657-DB4D-4E59-9BB6-9C2A11020C13}" srcId="{B6EA1160-7F8A-4126-8376-C44E264E6EA1}" destId="{016B6379-197D-4014-BBB5-7272361FA5ED}" srcOrd="0" destOrd="0" parTransId="{8D526268-2F08-4285-9EEA-ACD0B693F879}" sibTransId="{791199FC-FDB9-4DE9-A0A6-52879619A3C8}"/>
-    <dgm:cxn modelId="{C8A7134D-29D6-4AE5-AFFB-1706BB271EEA}" type="presOf" srcId="{DE0D542D-D583-46F8-AF81-5963C844620D}" destId="{EEF1E03F-C7C5-4626-9C13-2E78DD1D4267}" srcOrd="0" destOrd="0" presId="urn:diagrams.loki3.com/BracketList"/>
+    <dgm:cxn modelId="{06F5ADC8-64CC-416E-A504-58BD95BE6371}" type="presOf" srcId="{D19DA2C2-DBED-4C48-A059-92B1F02E952E}" destId="{2E54DBD1-1915-453C-B205-7D57F6596F56}" srcOrd="0" destOrd="1" presId="urn:diagrams.loki3.com/BracketList"/>
+    <dgm:cxn modelId="{3456690B-B173-48B8-86F7-97252F1597D5}" srcId="{E5D331DA-30E0-4D9E-AF95-9BED1C00B881}" destId="{96D22CE3-E99B-43B7-A890-8B3328F8E2E0}" srcOrd="1" destOrd="0" parTransId="{3DA8366F-C933-44CA-ADDF-18F73189EA6A}" sibTransId="{A42478D0-807D-4203-8347-8182C244F189}"/>
+    <dgm:cxn modelId="{8FE8D121-64DD-4D0A-B1E3-B860DA31B65D}" type="presOf" srcId="{67AAB135-0D51-4F78-B9C5-116756FDD4FD}" destId="{E4B80767-5737-4482-A6AF-D1C6CDF122DC}" srcOrd="0" destOrd="0" presId="urn:diagrams.loki3.com/BracketList"/>
+    <dgm:cxn modelId="{C2E89A0B-866F-45C1-9E43-09B489A3A4E8}" srcId="{D4570B03-06D1-496E-940D-E834C1A39D15}" destId="{39F54975-3C18-4047-B841-1E5ED79DA055}" srcOrd="5" destOrd="0" parTransId="{CEC1D58E-1AB3-4E72-A00C-84BAD892CD40}" sibTransId="{5DDE273F-5EAF-4DCF-9576-3CC5E69C990E}"/>
+    <dgm:cxn modelId="{86FD203E-7063-4D5F-A35C-3598D65669ED}" srcId="{02D6A755-2659-4714-A019-A60BD2DBF44D}" destId="{9357E48B-E7E0-4CA0-9ABC-FF0F47D16FFF}" srcOrd="0" destOrd="0" parTransId="{7581C13E-E6C9-4383-A784-20E62B70B3DC}" sibTransId="{F31CFC71-E692-4437-B605-955BBEFE5B3C}"/>
+    <dgm:cxn modelId="{CED7CC02-254C-4CB5-AA30-2B25713B0DE9}" srcId="{02D6A755-2659-4714-A019-A60BD2DBF44D}" destId="{D19DA2C2-DBED-4C48-A059-92B1F02E952E}" srcOrd="1" destOrd="0" parTransId="{2411435A-2DED-45FE-BAF2-EA5E2BAB2221}" sibTransId="{8B1C7915-ACF1-48A9-8CBC-03BA5CAA0EC8}"/>
+    <dgm:cxn modelId="{D60FD02C-D5E8-494B-B039-6EEC522D73AE}" type="presOf" srcId="{B8004FBE-713E-4F15-8885-85B9EA6E9A18}" destId="{051F707C-CB75-4D21-8C13-082BD2FF2D14}" srcOrd="0" destOrd="0" presId="urn:diagrams.loki3.com/BracketList"/>
+    <dgm:cxn modelId="{F0A4654E-4223-438B-A830-452AC96E48E2}" type="presOf" srcId="{20D280F0-91E7-42CA-9A03-571050C0CB16}" destId="{051F707C-CB75-4D21-8C13-082BD2FF2D14}" srcOrd="0" destOrd="1" presId="urn:diagrams.loki3.com/BracketList"/>
+    <dgm:cxn modelId="{E5D3C6D9-77FA-4A53-B8D1-9AFC12914D57}" srcId="{D4570B03-06D1-496E-940D-E834C1A39D15}" destId="{E5D331DA-30E0-4D9E-AF95-9BED1C00B881}" srcOrd="3" destOrd="0" parTransId="{0EEC3D0D-1968-4D98-B1E4-5BE2E7C9D046}" sibTransId="{0D12E0D9-447A-4318-A2D1-567184552CEB}"/>
+    <dgm:cxn modelId="{253CA61A-3D10-40C6-A6A5-EB9F6A55F5B0}" type="presOf" srcId="{E382FAAA-4FB2-477A-98B3-A2A120BAC348}" destId="{68C4F1F0-2F56-483B-8104-BEA79A7538A1}" srcOrd="0" destOrd="0" presId="urn:diagrams.loki3.com/BracketList"/>
+    <dgm:cxn modelId="{E8C2E0BE-83B9-42FF-9F2F-0017F48DCA71}" srcId="{DE0D542D-D583-46F8-AF81-5963C844620D}" destId="{B410AD1F-A2B3-49B3-8BE2-CA1B2963672B}" srcOrd="1" destOrd="0" parTransId="{703C4DDF-2819-43E6-95F5-DEA0F213ACDA}" sibTransId="{CCBF6D02-9F0B-4236-9549-FD1FC07A5984}"/>
+    <dgm:cxn modelId="{A96622E3-BC84-4F67-BC21-F7E183C9238B}" srcId="{CFC255E3-F313-4F68-A8BE-AA9A0E7B2920}" destId="{EF4D839F-1954-4FEA-BC1D-6A6FE5E5C4E4}" srcOrd="1" destOrd="0" parTransId="{ABA9D00D-FA58-4C5C-A960-9BF9EC11A01B}" sibTransId="{BFF19C4C-6C38-488B-B9A1-292A32DD8C60}"/>
+    <dgm:cxn modelId="{99E6DEB9-6BD5-4EFC-87D0-EC8AA52BEB00}" srcId="{39F54975-3C18-4047-B841-1E5ED79DA055}" destId="{E382FAAA-4FB2-477A-98B3-A2A120BAC348}" srcOrd="0" destOrd="0" parTransId="{A26A0720-9BE4-44E9-89C9-7F9980634043}" sibTransId="{92B8D365-A3DA-4EE7-BA70-DC7D10A7653D}"/>
     <dgm:cxn modelId="{C7CA2681-FAC3-474C-B622-629EB19F99E9}" type="presParOf" srcId="{49162F80-9F02-44A6-B8BB-9C145D32E9A6}" destId="{93D76702-C2A8-4552-960B-C2CCD4981C99}" srcOrd="0" destOrd="0" presId="urn:diagrams.loki3.com/BracketList"/>
     <dgm:cxn modelId="{38CA16D5-C4E9-4454-9705-C78453B60C5A}" type="presParOf" srcId="{93D76702-C2A8-4552-960B-C2CCD4981C99}" destId="{EEF1E03F-C7C5-4626-9C13-2E78DD1D4267}" srcOrd="0" destOrd="0" presId="urn:diagrams.loki3.com/BracketList"/>
     <dgm:cxn modelId="{E10DDCF7-A95D-4D15-B04C-07349A4D6BCA}" type="presParOf" srcId="{93D76702-C2A8-4552-960B-C2CCD4981C99}" destId="{A26B1DE6-CF11-4DDE-B44C-06D2D40056A5}" srcOrd="1" destOrd="0" presId="urn:diagrams.loki3.com/BracketList"/>
@@ -4978,7 +5006,7 @@
           <a:p>
             <a:fld id="{2BEA1986-BA3F-4B39-82E5-E5FA8BD8A6AC}" type="datetimeFigureOut">
               <a:rPr lang="en-US" smtClean="0"/>
-              <a:t>2026-08-07</a:t>
+              <a:t>2026-08-08</a:t>
             </a:fld>
             <a:endParaRPr lang="en-US"/>
           </a:p>
@@ -5504,7 +5532,7 @@
           <a:p>
             <a:fld id="{1D8BD707-D9CF-40AE-B4C6-C98DA3205C09}" type="datetimeFigureOut">
               <a:rPr lang="en-US"/>
-              <a:t>2026-08-07</a:t>
+              <a:t>2026-08-08</a:t>
             </a:fld>
             <a:endParaRPr lang="en-US"/>
           </a:p>
@@ -5728,7 +5756,7 @@
           <a:p>
             <a:fld id="{1D8BD707-D9CF-40AE-B4C6-C98DA3205C09}" type="datetimeFigureOut">
               <a:rPr lang="en-US"/>
-              <a:t>2026-08-07</a:t>
+              <a:t>2026-08-08</a:t>
             </a:fld>
             <a:endParaRPr lang="en-US"/>
           </a:p>
@@ -5989,7 +6017,7 @@
           <a:p>
             <a:fld id="{1D8BD707-D9CF-40AE-B4C6-C98DA3205C09}" type="datetimeFigureOut">
               <a:rPr lang="en-US"/>
-              <a:t>2026-08-07</a:t>
+              <a:t>2026-08-08</a:t>
             </a:fld>
             <a:endParaRPr lang="en-US"/>
           </a:p>
@@ -6184,7 +6212,7 @@
           <a:p>
             <a:fld id="{1D8BD707-D9CF-40AE-B4C6-C98DA3205C09}" type="datetimeFigureOut">
               <a:rPr lang="en-US"/>
-              <a:t>2026-08-07</a:t>
+              <a:t>2026-08-08</a:t>
             </a:fld>
             <a:endParaRPr lang="en-US"/>
           </a:p>
@@ -6350,7 +6378,7 @@
           <a:p>
             <a:fld id="{1D8BD707-D9CF-40AE-B4C6-C98DA3205C09}" type="datetimeFigureOut">
               <a:rPr lang="en-US"/>
-              <a:t>2026-08-07</a:t>
+              <a:t>2026-08-08</a:t>
             </a:fld>
             <a:endParaRPr lang="en-US"/>
           </a:p>
@@ -6672,7 +6700,7 @@
           <a:p>
             <a:fld id="{1D8BD707-D9CF-40AE-B4C6-C98DA3205C09}" type="datetimeFigureOut">
               <a:rPr lang="en-US"/>
-              <a:t>2026-08-07</a:t>
+              <a:t>2026-08-08</a:t>
             </a:fld>
             <a:endParaRPr lang="en-US"/>
           </a:p>
@@ -25606,8 +25634,8 @@
         </p:nvSpPr>
         <p:spPr>
           <a:xfrm>
-            <a:off x="129427" y="665850"/>
-            <a:ext cx="2755380" cy="2043508"/>
+            <a:off x="-523352" y="1883400"/>
+            <a:ext cx="2755380" cy="689291"/>
           </a:xfrm>
           <a:prstGeom prst="rect">
             <a:avLst/>
@@ -25624,24 +25652,9 @@
             </a:endParaRPr>
           </a:p>
           <a:p>
-            <a:r>
-              <a:rPr lang="en-US" sz="1100" dirty="0" smtClean="0">
-                <a:latin typeface="Arial Black" panose="020B0A04020102020204" pitchFamily="34" charset="0"/>
-              </a:rPr>
-              <a:t>1-Manual </a:t>
-            </a:r>
-            <a:r>
-              <a:rPr lang="en-US" sz="1100" dirty="0">
-                <a:latin typeface="Arial Black" panose="020B0A04020102020204" pitchFamily="34" charset="0"/>
-              </a:rPr>
-              <a:t>PDF search is slow and </a:t>
-            </a:r>
-            <a:r>
-              <a:rPr lang="en-US" sz="1100" dirty="0" smtClean="0">
-                <a:latin typeface="Arial Black" panose="020B0A04020102020204" pitchFamily="34" charset="0"/>
-              </a:rPr>
-              <a:t>tedious</a:t>
-            </a:r>
+            <a:endParaRPr lang="en-US" sz="1100" dirty="0">
+              <a:latin typeface="Arial Black" panose="020B0A04020102020204" pitchFamily="34" charset="0"/>
+            </a:endParaRPr>
           </a:p>
           <a:p>
             <a:endParaRPr lang="en-US" sz="1100" dirty="0">
@@ -25649,81 +25662,9 @@
             </a:endParaRPr>
           </a:p>
           <a:p>
-            <a:r>
-              <a:rPr lang="en-US" sz="1100" dirty="0" smtClean="0">
-                <a:latin typeface="Arial Black" panose="020B0A04020102020204" pitchFamily="34" charset="0"/>
-              </a:rPr>
-              <a:t>2-Keyword </a:t>
-            </a:r>
-            <a:r>
-              <a:rPr lang="en-US" sz="1100" dirty="0">
-                <a:latin typeface="Arial Black" panose="020B0A04020102020204" pitchFamily="34" charset="0"/>
-              </a:rPr>
-              <a:t>search misses </a:t>
-            </a:r>
-            <a:r>
-              <a:rPr lang="en-US" sz="1100" dirty="0">
-                <a:latin typeface="Arial Black" panose="020B0A04020102020204" pitchFamily="34" charset="0"/>
-                <a:cs typeface="Arial" panose="020B0604020202020204" pitchFamily="34" charset="0"/>
-              </a:rPr>
-              <a:t>paraphrased</a:t>
-            </a:r>
-            <a:r>
-              <a:rPr lang="en-US" sz="1100" dirty="0">
-                <a:latin typeface="Arial Black" panose="020B0A04020102020204" pitchFamily="34" charset="0"/>
-              </a:rPr>
-              <a:t> </a:t>
-            </a:r>
-            <a:r>
-              <a:rPr lang="en-US" sz="1100" dirty="0" smtClean="0">
-                <a:latin typeface="Arial Black" panose="020B0A04020102020204" pitchFamily="34" charset="0"/>
-              </a:rPr>
-              <a:t>content</a:t>
-            </a:r>
-          </a:p>
-          <a:p>
             <a:endParaRPr lang="en-US" sz="1100" dirty="0">
               <a:latin typeface="Arial Black" panose="020B0A04020102020204" pitchFamily="34" charset="0"/>
             </a:endParaRPr>
-          </a:p>
-          <a:p>
-            <a:r>
-              <a:rPr lang="en-US" sz="1100" dirty="0" smtClean="0">
-                <a:latin typeface="Arial Black" panose="020B0A04020102020204" pitchFamily="34" charset="0"/>
-              </a:rPr>
-              <a:t>3-Generic </a:t>
-            </a:r>
-            <a:r>
-              <a:rPr lang="en-US" sz="1100" dirty="0">
-                <a:latin typeface="Arial Black" panose="020B0A04020102020204" pitchFamily="34" charset="0"/>
-              </a:rPr>
-              <a:t>LLMs fabricate protocol </a:t>
-            </a:r>
-            <a:r>
-              <a:rPr lang="en-US" sz="1100" dirty="0" smtClean="0">
-                <a:latin typeface="Arial Black" panose="020B0A04020102020204" pitchFamily="34" charset="0"/>
-              </a:rPr>
-              <a:t>details</a:t>
-            </a:r>
-          </a:p>
-          <a:p>
-            <a:endParaRPr lang="en-US" sz="1100" dirty="0">
-              <a:latin typeface="Arial Black" panose="020B0A04020102020204" pitchFamily="34" charset="0"/>
-            </a:endParaRPr>
-          </a:p>
-          <a:p>
-            <a:r>
-              <a:rPr lang="en-US" sz="1100" dirty="0" smtClean="0">
-                <a:latin typeface="Arial Black" panose="020B0A04020102020204" pitchFamily="34" charset="0"/>
-              </a:rPr>
-              <a:t>4-No </a:t>
-            </a:r>
-            <a:r>
-              <a:rPr lang="en-US" sz="1100" dirty="0">
-                <a:latin typeface="Arial Black" panose="020B0A04020102020204" pitchFamily="34" charset="0"/>
-              </a:rPr>
-              <a:t>tool offers cited, spec-grounded answers</a:t>
-            </a:r>
           </a:p>
         </p:txBody>
       </p:sp>
@@ -25987,7 +25928,7 @@
         <p:spPr>
           <a:xfrm>
             <a:off x="2976026" y="645684"/>
-            <a:ext cx="2644724" cy="2382062"/>
+            <a:ext cx="2644724" cy="858568"/>
           </a:xfrm>
           <a:prstGeom prst="rect">
             <a:avLst/>
@@ -26004,24 +25945,9 @@
             </a:endParaRPr>
           </a:p>
           <a:p>
-            <a:r>
-              <a:rPr lang="en-US" sz="1100" dirty="0" smtClean="0">
-                <a:latin typeface="Arial Black" panose="020B0A04020102020204" pitchFamily="34" charset="0"/>
-              </a:rPr>
-              <a:t>Telecom </a:t>
-            </a:r>
-            <a:r>
-              <a:rPr lang="en-US" sz="1100" dirty="0" smtClean="0">
-                <a:latin typeface="Arial Black" panose="020B0A04020102020204" pitchFamily="34" charset="0"/>
-              </a:rPr>
-              <a:t>LLM </a:t>
-            </a:r>
-            <a:r>
-              <a:rPr lang="en-US" sz="1100" dirty="0" smtClean="0">
-                <a:latin typeface="Arial Black" panose="020B0A04020102020204" pitchFamily="34" charset="0"/>
-              </a:rPr>
-              <a:t>RAG</a:t>
-            </a:r>
+            <a:endParaRPr lang="en-US" sz="1100" dirty="0">
+              <a:latin typeface="Arial Black" panose="020B0A04020102020204" pitchFamily="34" charset="0"/>
+            </a:endParaRPr>
           </a:p>
           <a:p>
             <a:endParaRPr lang="en-US" sz="1100" dirty="0">
@@ -26029,93 +25955,14 @@
             </a:endParaRPr>
           </a:p>
           <a:p>
-            <a:r>
-              <a:rPr lang="en-US" sz="1100" dirty="0" smtClean="0">
-                <a:latin typeface="Arial Black" panose="020B0A04020102020204" pitchFamily="34" charset="0"/>
-              </a:rPr>
-              <a:t>1-Purpose-built </a:t>
-            </a:r>
-            <a:r>
-              <a:rPr lang="en-US" sz="1100" dirty="0">
-                <a:latin typeface="Arial Black" panose="020B0A04020102020204" pitchFamily="34" charset="0"/>
-              </a:rPr>
-              <a:t>specifically for </a:t>
-            </a:r>
-            <a:r>
-              <a:rPr lang="en-US" sz="1100" dirty="0" smtClean="0">
-                <a:latin typeface="Arial Black" panose="020B0A04020102020204" pitchFamily="34" charset="0"/>
-              </a:rPr>
-              <a:t>       telecom papers</a:t>
-            </a:r>
+            <a:endParaRPr lang="en-US" sz="1100" dirty="0">
+              <a:latin typeface="Arial Black" panose="020B0A04020102020204" pitchFamily="34" charset="0"/>
+            </a:endParaRPr>
           </a:p>
           <a:p>
             <a:endParaRPr lang="en-US" sz="1100" dirty="0">
               <a:latin typeface="Arial Black" panose="020B0A04020102020204" pitchFamily="34" charset="0"/>
             </a:endParaRPr>
-          </a:p>
-          <a:p>
-            <a:r>
-              <a:rPr lang="en-US" sz="1100" dirty="0" smtClean="0">
-                <a:latin typeface="Arial Black" panose="020B0A04020102020204" pitchFamily="34" charset="0"/>
-              </a:rPr>
-              <a:t>2-Fully </a:t>
-            </a:r>
-            <a:r>
-              <a:rPr lang="en-US" sz="1100" dirty="0">
-                <a:latin typeface="Arial Black" panose="020B0A04020102020204" pitchFamily="34" charset="0"/>
-              </a:rPr>
-              <a:t>local: embeddings, vector store, </a:t>
-            </a:r>
-            <a:r>
-              <a:rPr lang="en-US" sz="1100" dirty="0" smtClean="0">
-                <a:latin typeface="Arial Black" panose="020B0A04020102020204" pitchFamily="34" charset="0"/>
-              </a:rPr>
-              <a:t>re-ranking</a:t>
-            </a:r>
-          </a:p>
-          <a:p>
-            <a:endParaRPr lang="en-US" sz="1100" dirty="0">
-              <a:latin typeface="Arial Black" panose="020B0A04020102020204" pitchFamily="34" charset="0"/>
-            </a:endParaRPr>
-          </a:p>
-          <a:p>
-            <a:r>
-              <a:rPr lang="en-US" sz="1100" dirty="0" smtClean="0">
-                <a:latin typeface="Arial Black" panose="020B0A04020102020204" pitchFamily="34" charset="0"/>
-              </a:rPr>
-              <a:t>3-Every </a:t>
-            </a:r>
-            <a:r>
-              <a:rPr lang="en-US" sz="1100" dirty="0">
-                <a:latin typeface="Arial Black" panose="020B0A04020102020204" pitchFamily="34" charset="0"/>
-              </a:rPr>
-              <a:t>answer cites: TS number, Release, Section, </a:t>
-            </a:r>
-            <a:r>
-              <a:rPr lang="en-US" sz="1100" dirty="0" smtClean="0">
-                <a:latin typeface="Arial Black" panose="020B0A04020102020204" pitchFamily="34" charset="0"/>
-              </a:rPr>
-              <a:t>page</a:t>
-            </a:r>
-          </a:p>
-          <a:p>
-            <a:endParaRPr lang="en-US" sz="1100" dirty="0">
-              <a:latin typeface="Arial Black" panose="020B0A04020102020204" pitchFamily="34" charset="0"/>
-            </a:endParaRPr>
-          </a:p>
-          <a:p>
-            <a:r>
-              <a:rPr lang="en-US" sz="1100" dirty="0" smtClean="0">
-                <a:latin typeface="Arial Black" panose="020B0A04020102020204" pitchFamily="34" charset="0"/>
-              </a:rPr>
-              <a:t>4-Integrated </a:t>
-            </a:r>
-            <a:r>
-              <a:rPr lang="en-US" sz="1100" dirty="0">
-                <a:latin typeface="Arial Black" panose="020B0A04020102020204" pitchFamily="34" charset="0"/>
-              </a:rPr>
-              <a:t>into RANPilotAI — no tool switching</a:t>
-            </a:r>
           </a:p>
         </p:txBody>
       </p:sp>
@@ -26428,6 +26275,399 @@
               <a:rPr spc="-25" dirty="0"/>
               <a:t>47</a:t>
             </a:r>
+          </a:p>
+        </p:txBody>
+      </p:sp>
+      <p:sp>
+        <p:nvSpPr>
+          <p:cNvPr id="7" name="Rounded Rectangle 6"/>
+          <p:cNvSpPr/>
+          <p:nvPr/>
+        </p:nvSpPr>
+        <p:spPr>
+          <a:xfrm>
+            <a:off x="161394" y="820430"/>
+            <a:ext cx="2524873" cy="417213"/>
+          </a:xfrm>
+          <a:prstGeom prst="roundRect">
+            <a:avLst/>
+          </a:prstGeom>
+        </p:spPr>
+        <p:style>
+          <a:lnRef idx="2">
+            <a:schemeClr val="accent1">
+              <a:shade val="50000"/>
+            </a:schemeClr>
+          </a:lnRef>
+          <a:fillRef idx="1">
+            <a:schemeClr val="accent1"/>
+          </a:fillRef>
+          <a:effectRef idx="0">
+            <a:schemeClr val="accent1"/>
+          </a:effectRef>
+          <a:fontRef idx="minor">
+            <a:schemeClr val="lt1"/>
+          </a:fontRef>
+        </p:style>
+        <p:txBody>
+          <a:bodyPr rtlCol="0" anchor="ctr"/>
+          <a:lstStyle/>
+          <a:p>
+            <a:pPr algn="l"/>
+            <a:r>
+              <a:rPr lang="en-US" sz="1100" dirty="0" smtClean="0">
+                <a:latin typeface="Arial Black" panose="020B0A04020102020204" pitchFamily="34" charset="0"/>
+              </a:rPr>
+              <a:t>Manual PDF search is slow and tedious</a:t>
+            </a:r>
+            <a:endParaRPr lang="en-US" sz="1100" dirty="0">
+              <a:latin typeface="Arial Black" panose="020B0A04020102020204" pitchFamily="34" charset="0"/>
+            </a:endParaRPr>
+          </a:p>
+        </p:txBody>
+      </p:sp>
+      <p:sp>
+        <p:nvSpPr>
+          <p:cNvPr id="24" name="Rounded Rectangle 23"/>
+          <p:cNvSpPr/>
+          <p:nvPr/>
+        </p:nvSpPr>
+        <p:spPr>
+          <a:xfrm>
+            <a:off x="144286" y="1332240"/>
+            <a:ext cx="2524873" cy="414504"/>
+          </a:xfrm>
+          <a:prstGeom prst="roundRect">
+            <a:avLst/>
+          </a:prstGeom>
+        </p:spPr>
+        <p:style>
+          <a:lnRef idx="2">
+            <a:schemeClr val="accent1">
+              <a:shade val="50000"/>
+            </a:schemeClr>
+          </a:lnRef>
+          <a:fillRef idx="1">
+            <a:schemeClr val="accent1"/>
+          </a:fillRef>
+          <a:effectRef idx="0">
+            <a:schemeClr val="accent1"/>
+          </a:effectRef>
+          <a:fontRef idx="minor">
+            <a:schemeClr val="lt1"/>
+          </a:fontRef>
+        </p:style>
+        <p:txBody>
+          <a:bodyPr rtlCol="0" anchor="ctr"/>
+          <a:lstStyle/>
+          <a:p>
+            <a:pPr algn="l"/>
+            <a:r>
+              <a:rPr lang="en-US" sz="1100" dirty="0" smtClean="0">
+                <a:latin typeface="Arial Black" panose="020B0A04020102020204" pitchFamily="34" charset="0"/>
+              </a:rPr>
+              <a:t>Keyword search misses </a:t>
+            </a:r>
+            <a:r>
+              <a:rPr lang="en-US" sz="1100" dirty="0" smtClean="0">
+                <a:latin typeface="Arial Black" panose="020B0A04020102020204" pitchFamily="34" charset="0"/>
+                <a:cs typeface="Arial" panose="020B0604020202020204" pitchFamily="34" charset="0"/>
+              </a:rPr>
+              <a:t>paraphrased</a:t>
+            </a:r>
+            <a:r>
+              <a:rPr lang="en-US" sz="1100" dirty="0" smtClean="0">
+                <a:latin typeface="Arial Black" panose="020B0A04020102020204" pitchFamily="34" charset="0"/>
+              </a:rPr>
+              <a:t> content</a:t>
+            </a:r>
+            <a:endParaRPr lang="en-US" sz="1100" dirty="0" smtClean="0">
+              <a:latin typeface="Arial Black" panose="020B0A04020102020204" pitchFamily="34" charset="0"/>
+            </a:endParaRPr>
+          </a:p>
+        </p:txBody>
+      </p:sp>
+      <p:sp>
+        <p:nvSpPr>
+          <p:cNvPr id="25" name="Rounded Rectangle 24"/>
+          <p:cNvSpPr/>
+          <p:nvPr/>
+        </p:nvSpPr>
+        <p:spPr>
+          <a:xfrm>
+            <a:off x="146100" y="1904984"/>
+            <a:ext cx="2524873" cy="405003"/>
+          </a:xfrm>
+          <a:prstGeom prst="roundRect">
+            <a:avLst/>
+          </a:prstGeom>
+        </p:spPr>
+        <p:style>
+          <a:lnRef idx="2">
+            <a:schemeClr val="accent1">
+              <a:shade val="50000"/>
+            </a:schemeClr>
+          </a:lnRef>
+          <a:fillRef idx="1">
+            <a:schemeClr val="accent1"/>
+          </a:fillRef>
+          <a:effectRef idx="0">
+            <a:schemeClr val="accent1"/>
+          </a:effectRef>
+          <a:fontRef idx="minor">
+            <a:schemeClr val="lt1"/>
+          </a:fontRef>
+        </p:style>
+        <p:txBody>
+          <a:bodyPr rtlCol="0" anchor="ctr"/>
+          <a:lstStyle/>
+          <a:p>
+            <a:pPr algn="l"/>
+            <a:r>
+              <a:rPr lang="en-US" sz="1100" dirty="0" smtClean="0">
+                <a:latin typeface="Arial Black" panose="020B0A04020102020204" pitchFamily="34" charset="0"/>
+              </a:rPr>
+              <a:t>Generic LLMs fabricate protocol details</a:t>
+            </a:r>
+            <a:endParaRPr lang="en-US" sz="1100" dirty="0" smtClean="0">
+              <a:latin typeface="Arial Black" panose="020B0A04020102020204" pitchFamily="34" charset="0"/>
+            </a:endParaRPr>
+          </a:p>
+        </p:txBody>
+      </p:sp>
+      <p:sp>
+        <p:nvSpPr>
+          <p:cNvPr id="26" name="Rounded Rectangle 25"/>
+          <p:cNvSpPr/>
+          <p:nvPr/>
+        </p:nvSpPr>
+        <p:spPr>
+          <a:xfrm>
+            <a:off x="161394" y="2414085"/>
+            <a:ext cx="2524873" cy="597741"/>
+          </a:xfrm>
+          <a:prstGeom prst="roundRect">
+            <a:avLst/>
+          </a:prstGeom>
+        </p:spPr>
+        <p:style>
+          <a:lnRef idx="2">
+            <a:schemeClr val="accent1">
+              <a:shade val="50000"/>
+            </a:schemeClr>
+          </a:lnRef>
+          <a:fillRef idx="1">
+            <a:schemeClr val="accent1"/>
+          </a:fillRef>
+          <a:effectRef idx="0">
+            <a:schemeClr val="accent1"/>
+          </a:effectRef>
+          <a:fontRef idx="minor">
+            <a:schemeClr val="lt1"/>
+          </a:fontRef>
+        </p:style>
+        <p:txBody>
+          <a:bodyPr rtlCol="0" anchor="ctr"/>
+          <a:lstStyle/>
+          <a:p>
+            <a:pPr algn="l"/>
+            <a:r>
+              <a:rPr lang="en-US" sz="1100" dirty="0" smtClean="0">
+                <a:latin typeface="Arial Black" panose="020B0A04020102020204" pitchFamily="34" charset="0"/>
+              </a:rPr>
+              <a:t>No tool offers cited, spec-grounded answers</a:t>
+            </a:r>
+            <a:endParaRPr lang="en-US" sz="1100" dirty="0">
+              <a:latin typeface="Arial Black" panose="020B0A04020102020204" pitchFamily="34" charset="0"/>
+            </a:endParaRPr>
+          </a:p>
+        </p:txBody>
+      </p:sp>
+      <p:sp>
+        <p:nvSpPr>
+          <p:cNvPr id="27" name="Rounded Rectangle 26"/>
+          <p:cNvSpPr/>
+          <p:nvPr/>
+        </p:nvSpPr>
+        <p:spPr>
+          <a:xfrm>
+            <a:off x="3046880" y="817160"/>
+            <a:ext cx="2524873" cy="417213"/>
+          </a:xfrm>
+          <a:prstGeom prst="roundRect">
+            <a:avLst/>
+          </a:prstGeom>
+        </p:spPr>
+        <p:style>
+          <a:lnRef idx="2">
+            <a:schemeClr val="accent1">
+              <a:shade val="50000"/>
+            </a:schemeClr>
+          </a:lnRef>
+          <a:fillRef idx="1">
+            <a:schemeClr val="accent1"/>
+          </a:fillRef>
+          <a:effectRef idx="0">
+            <a:schemeClr val="accent1"/>
+          </a:effectRef>
+          <a:fontRef idx="minor">
+            <a:schemeClr val="lt1"/>
+          </a:fontRef>
+        </p:style>
+        <p:txBody>
+          <a:bodyPr rtlCol="0" anchor="ctr"/>
+          <a:lstStyle/>
+          <a:p>
+            <a:r>
+              <a:rPr lang="en-US" sz="1100" dirty="0" smtClean="0">
+                <a:latin typeface="Arial Black" panose="020B0A04020102020204" pitchFamily="34" charset="0"/>
+              </a:rPr>
+              <a:t>Telecom LLM RAG</a:t>
+            </a:r>
+            <a:endParaRPr lang="en-US" sz="1100" dirty="0" smtClean="0">
+              <a:latin typeface="Arial Black" panose="020B0A04020102020204" pitchFamily="34" charset="0"/>
+            </a:endParaRPr>
+          </a:p>
+        </p:txBody>
+      </p:sp>
+      <p:sp>
+        <p:nvSpPr>
+          <p:cNvPr id="28" name="Rounded Rectangle 27"/>
+          <p:cNvSpPr/>
+          <p:nvPr/>
+        </p:nvSpPr>
+        <p:spPr>
+          <a:xfrm>
+            <a:off x="3046879" y="1330885"/>
+            <a:ext cx="2524873" cy="417213"/>
+          </a:xfrm>
+          <a:prstGeom prst="roundRect">
+            <a:avLst/>
+          </a:prstGeom>
+        </p:spPr>
+        <p:style>
+          <a:lnRef idx="2">
+            <a:schemeClr val="accent1">
+              <a:shade val="50000"/>
+            </a:schemeClr>
+          </a:lnRef>
+          <a:fillRef idx="1">
+            <a:schemeClr val="accent1"/>
+          </a:fillRef>
+          <a:effectRef idx="0">
+            <a:schemeClr val="accent1"/>
+          </a:effectRef>
+          <a:fontRef idx="minor">
+            <a:schemeClr val="lt1"/>
+          </a:fontRef>
+        </p:style>
+        <p:txBody>
+          <a:bodyPr rtlCol="0" anchor="ctr"/>
+          <a:lstStyle/>
+          <a:p>
+            <a:r>
+              <a:rPr lang="en-US" sz="1100" dirty="0" smtClean="0">
+                <a:latin typeface="Arial Black" panose="020B0A04020102020204" pitchFamily="34" charset="0"/>
+              </a:rPr>
+              <a:t>Purpose-built specifically for telecom papers </a:t>
+            </a:r>
+            <a:endParaRPr lang="en-US" sz="1100" dirty="0" smtClean="0">
+              <a:latin typeface="Arial Black" panose="020B0A04020102020204" pitchFamily="34" charset="0"/>
+            </a:endParaRPr>
+          </a:p>
+        </p:txBody>
+      </p:sp>
+      <p:sp>
+        <p:nvSpPr>
+          <p:cNvPr id="29" name="Rounded Rectangle 28"/>
+          <p:cNvSpPr/>
+          <p:nvPr/>
+        </p:nvSpPr>
+        <p:spPr>
+          <a:xfrm>
+            <a:off x="3046879" y="1884609"/>
+            <a:ext cx="2524873" cy="417213"/>
+          </a:xfrm>
+          <a:prstGeom prst="roundRect">
+            <a:avLst/>
+          </a:prstGeom>
+        </p:spPr>
+        <p:style>
+          <a:lnRef idx="2">
+            <a:schemeClr val="accent1">
+              <a:shade val="50000"/>
+            </a:schemeClr>
+          </a:lnRef>
+          <a:fillRef idx="1">
+            <a:schemeClr val="accent1"/>
+          </a:fillRef>
+          <a:effectRef idx="0">
+            <a:schemeClr val="accent1"/>
+          </a:effectRef>
+          <a:fontRef idx="minor">
+            <a:schemeClr val="lt1"/>
+          </a:fontRef>
+        </p:style>
+        <p:txBody>
+          <a:bodyPr rtlCol="0" anchor="ctr"/>
+          <a:lstStyle/>
+          <a:p>
+            <a:r>
+              <a:rPr lang="en-US" sz="1100" dirty="0" smtClean="0">
+                <a:latin typeface="Arial Black" panose="020B0A04020102020204" pitchFamily="34" charset="0"/>
+              </a:rPr>
+              <a:t>Fully local: embeddings, vector store, re-ranking</a:t>
+            </a:r>
+            <a:endParaRPr lang="en-US" sz="1100" dirty="0" smtClean="0">
+              <a:latin typeface="Arial Black" panose="020B0A04020102020204" pitchFamily="34" charset="0"/>
+            </a:endParaRPr>
+          </a:p>
+        </p:txBody>
+      </p:sp>
+      <p:sp>
+        <p:nvSpPr>
+          <p:cNvPr id="30" name="Rounded Rectangle 29"/>
+          <p:cNvSpPr/>
+          <p:nvPr/>
+        </p:nvSpPr>
+        <p:spPr>
+          <a:xfrm>
+            <a:off x="3046879" y="2420207"/>
+            <a:ext cx="2524873" cy="591619"/>
+          </a:xfrm>
+          <a:prstGeom prst="roundRect">
+            <a:avLst/>
+          </a:prstGeom>
+        </p:spPr>
+        <p:style>
+          <a:lnRef idx="2">
+            <a:schemeClr val="accent1">
+              <a:shade val="50000"/>
+            </a:schemeClr>
+          </a:lnRef>
+          <a:fillRef idx="1">
+            <a:schemeClr val="accent1"/>
+          </a:fillRef>
+          <a:effectRef idx="0">
+            <a:schemeClr val="accent1"/>
+          </a:effectRef>
+          <a:fontRef idx="minor">
+            <a:schemeClr val="lt1"/>
+          </a:fontRef>
+        </p:style>
+        <p:txBody>
+          <a:bodyPr rtlCol="0" anchor="ctr"/>
+          <a:lstStyle/>
+          <a:p>
+            <a:r>
+              <a:rPr lang="en-US" sz="1100" dirty="0" smtClean="0">
+                <a:latin typeface="Arial Black" panose="020B0A04020102020204" pitchFamily="34" charset="0"/>
+              </a:rPr>
+              <a:t>Every answer cites: TS number, Release, Section, page</a:t>
+            </a:r>
+            <a:endParaRPr lang="en-US" sz="1100" dirty="0" smtClean="0">
+              <a:latin typeface="Arial Black" panose="020B0A04020102020204" pitchFamily="34" charset="0"/>
+            </a:endParaRPr>
           </a:p>
         </p:txBody>
       </p:sp>
@@ -27425,15 +27665,7 @@
                   <a:schemeClr val="lt1"/>
                 </a:solidFill>
               </a:rPr>
-              <a:t>. </a:t>
-            </a:r>
-            <a:r>
-              <a:rPr lang="en-US" sz="1000" dirty="0" smtClean="0">
-                <a:solidFill>
-                  <a:schemeClr val="lt1"/>
-                </a:solidFill>
-              </a:rPr>
-              <a:t>Embedding </a:t>
+              <a:t>. Embedding </a:t>
             </a:r>
           </a:p>
           <a:p>
@@ -27588,15 +27820,7 @@
                   <a:schemeClr val="lt1"/>
                 </a:solidFill>
               </a:rPr>
-              <a:t>. </a:t>
-            </a:r>
-            <a:r>
-              <a:rPr lang="en-US" sz="1000" dirty="0" smtClean="0">
-                <a:solidFill>
-                  <a:schemeClr val="lt1"/>
-                </a:solidFill>
-              </a:rPr>
-              <a:t>Retrieval</a:t>
+              <a:t>. Retrieval</a:t>
             </a:r>
             <a:endParaRPr lang="en-US" sz="1000" dirty="0"/>
           </a:p>
@@ -28273,13 +28497,13 @@
   <p:clrMapOvr>
     <a:masterClrMapping/>
   </p:clrMapOvr>
-  <mc:AlternateContent xmlns:mc="http://schemas.openxmlformats.org/markup-compatibility/2006">
-    <mc:Choice xmlns:p14="http://schemas.microsoft.com/office/powerpoint/2010/main" Requires="p14">
+  <mc:AlternateContent xmlns:mc="http://schemas.openxmlformats.org/markup-compatibility/2006" xmlns:p14="http://schemas.microsoft.com/office/powerpoint/2010/main">
+    <mc:Choice Requires="p14">
       <p:transition spd="slow" p14:dur="800">
         <p:circle/>
       </p:transition>
     </mc:Choice>
-    <mc:Fallback>
+    <mc:Fallback xmlns="">
       <p:transition spd="slow">
         <p:circle/>
       </p:transition>
@@ -29338,6 +29562,30 @@
           </a:prstGeom>
         </p:spPr>
       </p:pic>
+      <p:pic>
+        <p:nvPicPr>
+          <p:cNvPr id="11" name="Picture 10"/>
+          <p:cNvPicPr>
+            <a:picLocks noChangeAspect="1"/>
+          </p:cNvPicPr>
+          <p:nvPr/>
+        </p:nvPicPr>
+        <p:blipFill>
+          <a:blip r:embed="rId6"/>
+          <a:stretch>
+            <a:fillRect/>
+          </a:stretch>
+        </p:blipFill>
+        <p:spPr>
+          <a:xfrm>
+            <a:off x="2248627" y="2597089"/>
+            <a:ext cx="3225073" cy="185182"/>
+          </a:xfrm>
+          <a:prstGeom prst="rect">
+            <a:avLst/>
+          </a:prstGeom>
+        </p:spPr>
+      </p:pic>
     </p:spTree>
   </p:cSld>
   <p:clrMapOvr>
@@ -29410,27 +29658,7 @@
                 <a:latin typeface="Arial Black"/>
                 <a:cs typeface="Arial Black"/>
               </a:rPr>
-              <a:t> what if I </a:t>
-            </a:r>
-            <a:r>
-              <a:rPr lang="en-US" sz="1400" spc="-170" dirty="0" smtClean="0">
-                <a:solidFill>
-                  <a:srgbClr val="FFFFFF"/>
-                </a:solidFill>
-                <a:latin typeface="Arial Black"/>
-                <a:cs typeface="Arial Black"/>
-              </a:rPr>
-              <a:t>asked </a:t>
-            </a:r>
-            <a:r>
-              <a:rPr lang="en-US" sz="1400" spc="-170" dirty="0" smtClean="0">
-                <a:solidFill>
-                  <a:srgbClr val="FFFFFF"/>
-                </a:solidFill>
-                <a:latin typeface="Arial Black"/>
-                <a:cs typeface="Arial Black"/>
-              </a:rPr>
-              <a:t>Non telecom  Question?</a:t>
+              <a:t> what if I asked Non telecom  Question?</a:t>
             </a:r>
             <a:endParaRPr sz="1400" dirty="0">
               <a:latin typeface="Arial Black"/>

</xml_diff>